<commit_message>
Abb. 3.34–3.40: OLAP-Abbildungen im Buchstil, 3.33 angeglichen
- Gemeinsamer Baustein quellen/kap3/_olap.py (Würfel mit Auswahl, Dimensionspfeile,
  Umsatz- und Produkttabelle, Legende); 3.33 nutzt ihn, „Dimension Produkt“ jetzt
  unter dem Pfeil wie in der ganzen Reihe
- 3.34 Rotation bzw. Pivoting, 3.35 Slice, 3.36 Dice (110 mm)
- 3.37 Drill-Down und Roll-Up, 3.38 Drill-Through, 3.39 Drill-Across (Querformat),
  3.40 Split und Merge (110 mm)
- Pfeilarten nach Bedeutung (durchgezogen = Aggregation, gestrichelt = Disaggregation);
  Summenfehler in 3.39 (Trekking Bike 12.000 statt 13.000) korrigiert
- Inventur und status.json aktualisiert

Co-Authored-By: Claude Opus 5.5 <noreply@anthropic.com>
Claude-Session: https://claude.ai/code/session_015a49Vr6vK6JHdw6trSezHk
</commit_message>
<xml_diff>
--- a/abbildungen/kap3/Einfacher_Datenwuerfel.pptx
+++ b/abbildungen/kap3/Einfacher_Datenwuerfel.pptx
@@ -7,7 +7,7 @@
   <p:sldIdLst>
     <p:sldId id="256" r:id="rId7"/>
   </p:sldIdLst>
-  <p:sldSz cx="3960000" cy="2538000" type="screen4x3"/>
+  <p:sldSz cx="3960000" cy="2412000" type="screen4x3"/>
   <p:notesSz cx="6858000" cy="9144000"/>
   <p:defaultTextStyle>
     <a:defPPr>
@@ -3096,7 +3096,7 @@
         </p:nvSpPr>
         <p:spPr>
           <a:xfrm>
-            <a:off x="1188000" y="403200"/>
+            <a:off x="1602000" y="313200"/>
             <a:ext cx="1440000" cy="280800"/>
           </a:xfrm>
           <a:custGeom>
@@ -3146,7 +3146,7 @@
         </p:nvSpPr>
         <p:spPr>
           <a:xfrm>
-            <a:off x="2196000" y="403200"/>
+            <a:off x="2610000" y="313200"/>
             <a:ext cx="432000" cy="1540800"/>
           </a:xfrm>
           <a:custGeom>
@@ -3196,7 +3196,7 @@
         </p:nvSpPr>
         <p:spPr>
           <a:xfrm>
-            <a:off x="1188000" y="684000"/>
+            <a:off x="1602000" y="594000"/>
             <a:ext cx="1008000" cy="1260000"/>
           </a:xfrm>
           <a:custGeom>
@@ -3246,7 +3246,7 @@
         </p:nvSpPr>
         <p:spPr>
           <a:xfrm>
-            <a:off x="1440000" y="684000"/>
+            <a:off x="1854000" y="594000"/>
             <a:ext cx="0" cy="1260000"/>
           </a:xfrm>
           <a:custGeom>
@@ -3290,7 +3290,7 @@
         </p:nvSpPr>
         <p:spPr>
           <a:xfrm>
-            <a:off x="1692000" y="684000"/>
+            <a:off x="2106000" y="594000"/>
             <a:ext cx="0" cy="1260000"/>
           </a:xfrm>
           <a:custGeom>
@@ -3334,7 +3334,7 @@
         </p:nvSpPr>
         <p:spPr>
           <a:xfrm>
-            <a:off x="1944000" y="684000"/>
+            <a:off x="2358000" y="594000"/>
             <a:ext cx="0" cy="1260000"/>
           </a:xfrm>
           <a:custGeom>
@@ -3378,7 +3378,7 @@
         </p:nvSpPr>
         <p:spPr>
           <a:xfrm>
-            <a:off x="1188000" y="936000"/>
+            <a:off x="1602000" y="846000"/>
             <a:ext cx="1008000" cy="0"/>
           </a:xfrm>
           <a:custGeom>
@@ -3422,7 +3422,7 @@
         </p:nvSpPr>
         <p:spPr>
           <a:xfrm>
-            <a:off x="1188000" y="1188000"/>
+            <a:off x="1602000" y="1098000"/>
             <a:ext cx="1008000" cy="0"/>
           </a:xfrm>
           <a:custGeom>
@@ -3466,7 +3466,7 @@
         </p:nvSpPr>
         <p:spPr>
           <a:xfrm>
-            <a:off x="1188000" y="1440000"/>
+            <a:off x="1602000" y="1350000"/>
             <a:ext cx="1008000" cy="0"/>
           </a:xfrm>
           <a:custGeom>
@@ -3510,7 +3510,7 @@
         </p:nvSpPr>
         <p:spPr>
           <a:xfrm>
-            <a:off x="1188000" y="1692000"/>
+            <a:off x="1602000" y="1602000"/>
             <a:ext cx="1008000" cy="0"/>
           </a:xfrm>
           <a:custGeom>
@@ -3554,7 +3554,7 @@
         </p:nvSpPr>
         <p:spPr>
           <a:xfrm>
-            <a:off x="1440000" y="403200"/>
+            <a:off x="1854000" y="313200"/>
             <a:ext cx="432000" cy="280800"/>
           </a:xfrm>
           <a:custGeom>
@@ -3598,7 +3598,7 @@
         </p:nvSpPr>
         <p:spPr>
           <a:xfrm>
-            <a:off x="1692000" y="403200"/>
+            <a:off x="2106000" y="313200"/>
             <a:ext cx="432000" cy="280800"/>
           </a:xfrm>
           <a:custGeom>
@@ -3642,7 +3642,7 @@
         </p:nvSpPr>
         <p:spPr>
           <a:xfrm>
-            <a:off x="1944000" y="403200"/>
+            <a:off x="2358000" y="313200"/>
             <a:ext cx="432000" cy="280800"/>
           </a:xfrm>
           <a:custGeom>
@@ -3686,7 +3686,7 @@
         </p:nvSpPr>
         <p:spPr>
           <a:xfrm>
-            <a:off x="1332000" y="590400"/>
+            <a:off x="1746000" y="500400"/>
             <a:ext cx="1008000" cy="0"/>
           </a:xfrm>
           <a:custGeom>
@@ -3730,7 +3730,7 @@
         </p:nvSpPr>
         <p:spPr>
           <a:xfrm>
-            <a:off x="1476000" y="496800"/>
+            <a:off x="1890000" y="406800"/>
             <a:ext cx="1008000" cy="0"/>
           </a:xfrm>
           <a:custGeom>
@@ -3774,7 +3774,7 @@
         </p:nvSpPr>
         <p:spPr>
           <a:xfrm>
-            <a:off x="2196000" y="655200"/>
+            <a:off x="2610000" y="565200"/>
             <a:ext cx="432000" cy="280800"/>
           </a:xfrm>
           <a:custGeom>
@@ -3818,7 +3818,7 @@
         </p:nvSpPr>
         <p:spPr>
           <a:xfrm>
-            <a:off x="2196000" y="907200"/>
+            <a:off x="2610000" y="817200"/>
             <a:ext cx="432000" cy="280800"/>
           </a:xfrm>
           <a:custGeom>
@@ -3862,7 +3862,7 @@
         </p:nvSpPr>
         <p:spPr>
           <a:xfrm>
-            <a:off x="2196000" y="1159200"/>
+            <a:off x="2610000" y="1069200"/>
             <a:ext cx="432000" cy="280800"/>
           </a:xfrm>
           <a:custGeom>
@@ -3906,7 +3906,7 @@
         </p:nvSpPr>
         <p:spPr>
           <a:xfrm>
-            <a:off x="2196000" y="1411200"/>
+            <a:off x="2610000" y="1321200"/>
             <a:ext cx="432000" cy="280800"/>
           </a:xfrm>
           <a:custGeom>
@@ -3950,7 +3950,7 @@
         </p:nvSpPr>
         <p:spPr>
           <a:xfrm>
-            <a:off x="2340000" y="590400"/>
+            <a:off x="2754000" y="500400"/>
             <a:ext cx="0" cy="1260000"/>
           </a:xfrm>
           <a:custGeom>
@@ -3994,7 +3994,7 @@
         </p:nvSpPr>
         <p:spPr>
           <a:xfrm>
-            <a:off x="2484000" y="496800"/>
+            <a:off x="2898000" y="406800"/>
             <a:ext cx="0" cy="1260000"/>
           </a:xfrm>
           <a:custGeom>
@@ -4038,7 +4038,7 @@
         </p:nvSpPr>
         <p:spPr>
           <a:xfrm>
-            <a:off x="1188000" y="403200"/>
+            <a:off x="1602000" y="313200"/>
             <a:ext cx="1440000" cy="1540800"/>
           </a:xfrm>
           <a:custGeom>
@@ -4095,7 +4095,7 @@
         </p:nvSpPr>
         <p:spPr>
           <a:xfrm>
-            <a:off x="1188000" y="403200"/>
+            <a:off x="1602000" y="313200"/>
             <a:ext cx="1440000" cy="280800"/>
           </a:xfrm>
           <a:custGeom>
@@ -4142,7 +4142,7 @@
         </p:nvSpPr>
         <p:spPr>
           <a:xfrm>
-            <a:off x="2196000" y="684000"/>
+            <a:off x="2610000" y="594000"/>
             <a:ext cx="0" cy="1260000"/>
           </a:xfrm>
           <a:custGeom>
@@ -4186,8 +4186,8 @@
         </p:nvSpPr>
         <p:spPr>
           <a:xfrm>
-            <a:off x="1339200" y="1224000"/>
-            <a:ext cx="705600" cy="180000"/>
+            <a:off x="1753200" y="1141857"/>
+            <a:ext cx="705600" cy="164287"/>
           </a:xfrm>
           <a:prstGeom prst="rect">
             <a:avLst/>
@@ -4200,7 +4200,7 @@
           </a:ln>
         </p:spPr>
         <p:txBody>
-          <a:bodyPr rtlCol="0" anchor="ctr" lIns="32400" rIns="32400" tIns="21600" bIns="21600" wrap="square">
+          <a:bodyPr rtlCol="0" anchor="ctr" lIns="7200" rIns="7200" tIns="3600" bIns="3600" wrap="square">
             <a:noAutofit/>
           </a:bodyPr>
           <a:lstStyle/>
@@ -4231,8 +4231,8 @@
         </p:nvSpPr>
         <p:spPr>
           <a:xfrm>
-            <a:off x="864000" y="684000"/>
-            <a:ext cx="1332000" cy="0"/>
+            <a:off x="1350000" y="594000"/>
+            <a:ext cx="1260000" cy="0"/>
           </a:xfrm>
           <a:custGeom>
             <a:avLst/>
@@ -4241,9 +4241,9 @@
             <a:cxnLst/>
             <a:rect l="l" t="t" r="r" b="b"/>
             <a:pathLst>
-              <a:path w="1332000" h="0">
+              <a:path w="1260000" h="0">
                 <a:moveTo>
-                  <a:pt x="1332000" y="0"/>
+                  <a:pt x="1260000" y="0"/>
                 </a:moveTo>
                 <a:lnTo>
                   <a:pt x="0" y="0"/>
@@ -4270,13 +4270,58 @@
       </p:sp>
       <p:sp>
         <p:nvSpPr>
-          <p:cNvPr id="28" name="Dimension Zeit"/>
+          <p:cNvPr id="28" name="Dimension Region"/>
           <p:cNvSpPr/>
           <p:nvPr/>
         </p:nvSpPr>
         <p:spPr>
           <a:xfrm>
-            <a:off x="2196000" y="684000"/>
+            <a:off x="2610000" y="158760"/>
+            <a:ext cx="669600" cy="435240"/>
+          </a:xfrm>
+          <a:custGeom>
+            <a:avLst/>
+            <a:gdLst/>
+            <a:ahLst/>
+            <a:cxnLst/>
+            <a:rect l="l" t="t" r="r" b="b"/>
+            <a:pathLst>
+              <a:path w="669600" h="435240">
+                <a:moveTo>
+                  <a:pt x="0" y="435240"/>
+                </a:moveTo>
+                <a:lnTo>
+                  <a:pt x="669600" y="0"/>
+                </a:lnTo>
+              </a:path>
+            </a:pathLst>
+          </a:custGeom>
+          <a:noFill/>
+          <a:ln w="15875">
+            <a:solidFill>
+              <a:srgbClr val="3A3F44"/>
+            </a:solidFill>
+            <a:round/>
+            <a:tailEnd type="triangle" w="med" len="med"/>
+          </a:ln>
+        </p:spPr>
+        <p:txBody>
+          <a:bodyPr rtlCol="0" anchor="ctr"/>
+          <a:lstStyle/>
+          <a:p>
+            <a:pPr algn="ctr"/>
+          </a:p>
+        </p:txBody>
+      </p:sp>
+      <p:sp>
+        <p:nvSpPr>
+          <p:cNvPr id="29" name="Dimension Zeit"/>
+          <p:cNvSpPr/>
+          <p:nvPr/>
+        </p:nvSpPr>
+        <p:spPr>
+          <a:xfrm>
+            <a:off x="2610000" y="594000"/>
             <a:ext cx="0" cy="1548000"/>
           </a:xfrm>
           <a:custGeom>
@@ -4315,59 +4360,14 @@
       </p:sp>
       <p:sp>
         <p:nvSpPr>
-          <p:cNvPr id="29" name="Dimension Region"/>
-          <p:cNvSpPr/>
-          <p:nvPr/>
-        </p:nvSpPr>
-        <p:spPr>
-          <a:xfrm>
-            <a:off x="2196000" y="248760"/>
-            <a:ext cx="669600" cy="435240"/>
-          </a:xfrm>
-          <a:custGeom>
-            <a:avLst/>
-            <a:gdLst/>
-            <a:ahLst/>
-            <a:cxnLst/>
-            <a:rect l="l" t="t" r="r" b="b"/>
-            <a:pathLst>
-              <a:path w="669600" h="435240">
-                <a:moveTo>
-                  <a:pt x="0" y="435240"/>
-                </a:moveTo>
-                <a:lnTo>
-                  <a:pt x="669600" y="0"/>
-                </a:lnTo>
-              </a:path>
-            </a:pathLst>
-          </a:custGeom>
-          <a:noFill/>
-          <a:ln w="15875">
-            <a:solidFill>
-              <a:srgbClr val="3A3F44"/>
-            </a:solidFill>
-            <a:round/>
-            <a:tailEnd type="triangle" w="med" len="med"/>
-          </a:ln>
-        </p:spPr>
-        <p:txBody>
-          <a:bodyPr rtlCol="0" anchor="ctr"/>
-          <a:lstStyle/>
-          <a:p>
-            <a:pPr algn="ctr"/>
-          </a:p>
-        </p:txBody>
-      </p:sp>
-      <p:sp>
-        <p:nvSpPr>
           <p:cNvPr id="30" name="Beschriftung Produkt"/>
           <p:cNvSpPr txBox="1"/>
           <p:nvPr/>
         </p:nvSpPr>
         <p:spPr>
           <a:xfrm>
-            <a:off x="18000" y="342000"/>
-            <a:ext cx="792000" cy="252000"/>
+            <a:off x="1035898" y="630000"/>
+            <a:ext cx="530102" cy="243014"/>
           </a:xfrm>
           <a:prstGeom prst="rect">
             <a:avLst/>
@@ -4375,7 +4375,7 @@
           <a:noFill/>
         </p:spPr>
         <p:txBody>
-          <a:bodyPr wrap="square" lIns="0" rIns="0" tIns="0" bIns="0" anchor="ctr">
+          <a:bodyPr wrap="square" lIns="0" rIns="0" tIns="0" bIns="0" anchor="t">
             <a:noAutofit/>
           </a:bodyPr>
           <a:lstStyle/>
@@ -4424,8 +4424,8 @@
         </p:nvSpPr>
         <p:spPr>
           <a:xfrm>
-            <a:off x="2919600" y="122760"/>
-            <a:ext cx="864000" cy="252000"/>
+            <a:off x="3322800" y="37253"/>
+            <a:ext cx="530102" cy="243014"/>
           </a:xfrm>
           <a:prstGeom prst="rect">
             <a:avLst/>
@@ -4482,8 +4482,8 @@
         </p:nvSpPr>
         <p:spPr>
           <a:xfrm>
-            <a:off x="1764000" y="2253600"/>
-            <a:ext cx="864000" cy="252000"/>
+            <a:off x="2344949" y="2163600"/>
+            <a:ext cx="530102" cy="243014"/>
           </a:xfrm>
           <a:prstGeom prst="rect">
             <a:avLst/>
@@ -4491,7 +4491,7 @@
           <a:noFill/>
         </p:spPr>
         <p:txBody>
-          <a:bodyPr wrap="square" lIns="0" rIns="0" tIns="0" bIns="0" anchor="ctr">
+          <a:bodyPr wrap="square" lIns="0" rIns="0" tIns="0" bIns="0" anchor="t">
             <a:noAutofit/>
           </a:bodyPr>
           <a:lstStyle/>

</xml_diff>